<commit_message>
refactor: silhouette as the only clustering metric
- Remove Davies-Bouldin, Calinski-Harabasz and ARI from notebooks and slides;
  k is chosen with elbow + silhouette + business sense
- Compare against real labels with crosstabs and plain counts instead of ARI
- Helpers: evaluar_clustering/tabla_metricas_k return silhouette only;
  plot_metricas_k replaced by plot_silueta_k
- Intro deck: rework the Caterpillar mining case slides with the real images
- Re-export all slide PDFs

Co-Authored-By: Claude Opus 5.5 <noreply@anthropic.com>
</commit_message>
<xml_diff>
--- a/01-kmeans/slides/Introducción a K-Means - UDEM.pptx
+++ b/01-kmeans/slides/Introducción a K-Means - UDEM.pptx
@@ -5026,7 +5026,7 @@
                 </a:solidFill>
                 <a:latin typeface="Courier New"/>
               </a:rPr>
-              <a:t>tabla = tabla_metricas_k(X, range(2, 11))             # 2. métricas por k</a:t>
+              <a:t>tabla = tabla_metricas_k(X, range(2, 11))             # 2. codo y silhouette por k</a:t>
             </a:r>
           </a:p>
           <a:p>
@@ -5516,7 +5516,7 @@
                           </a:solidFill>
                           <a:latin typeface="Calibri"/>
                         </a:rPr>
-                        <a:t>Codo + silhouette + DB + CH + negocio</a:t>
+                        <a:t>Codo + silhouette + negocio</a:t>
                       </a:r>
                     </a:p>
                   </a:txBody>
@@ -6068,7 +6068,7 @@
                 </a:solidFill>
                 <a:latin typeface="Calibri"/>
               </a:rPr>
-              <a:t>Elige k con varias métricas y con sentido de negocio</a:t>
+              <a:t>Elige k con codo, silhouette y sentido de negocio</a:t>
             </a:r>
           </a:p>
         </p:txBody>
@@ -9825,7 +9825,7 @@
         </p:nvGraphicFramePr>
         <p:xfrm>
           <a:off x="4800600" y="1188720"/>
-          <a:ext cx="3886200" cy="1828800"/>
+          <a:ext cx="3886200" cy="1463040"/>
         </p:xfrm>
         <a:graphic>
           <a:graphicData uri="http://schemas.openxmlformats.org/drawingml/2006/table">
@@ -9988,7 +9988,7 @@
                           </a:solidFill>
                           <a:latin typeface="Calibri"/>
                         </a:rPr>
-                        <a:t>Davies-Bouldin</a:t>
+                        <a:t>Gráfica de silueta</a:t>
                       </a:r>
                     </a:p>
                   </a:txBody>
@@ -10010,7 +10010,7 @@
                           </a:solidFill>
                           <a:latin typeface="Calibri"/>
                         </a:rPr>
-                        <a:t>Bajo</a:t>
+                        <a:t>Clusters parejos, sin negativos</a:t>
                       </a:r>
                     </a:p>
                   </a:txBody>
@@ -10021,52 +10021,6 @@
                   </a:tcPr>
                 </a:tc>
               </a:tr>
-              <a:tr h="365760">
-                <a:tc>
-                  <a:txBody>
-                    <a:bodyPr/>
-                    <a:lstStyle/>
-                    <a:p>
-                      <a:r>
-                        <a:rPr sz="1100" b="0" i="0">
-                          <a:solidFill>
-                            <a:srgbClr val="1A1A1A"/>
-                          </a:solidFill>
-                          <a:latin typeface="Calibri"/>
-                        </a:rPr>
-                        <a:t>Calinski-Harabasz</a:t>
-                      </a:r>
-                    </a:p>
-                  </a:txBody>
-                  <a:tcPr marL="73152" marR="73152" marT="27432" marB="27432">
-                    <a:solidFill>
-                      <a:srgbClr val="FFFFFF"/>
-                    </a:solidFill>
-                  </a:tcPr>
-                </a:tc>
-                <a:tc>
-                  <a:txBody>
-                    <a:bodyPr/>
-                    <a:lstStyle/>
-                    <a:p>
-                      <a:r>
-                        <a:rPr sz="1100" b="0" i="0">
-                          <a:solidFill>
-                            <a:srgbClr val="1A1A1A"/>
-                          </a:solidFill>
-                          <a:latin typeface="Calibri"/>
-                        </a:rPr>
-                        <a:t>Alto</a:t>
-                      </a:r>
-                    </a:p>
-                  </a:txBody>
-                  <a:tcPr marL="73152" marR="73152" marT="27432" marB="27432">
-                    <a:solidFill>
-                      <a:srgbClr val="FFFFFF"/>
-                    </a:solidFill>
-                  </a:tcPr>
-                </a:tc>
-              </a:tr>
             </a:tbl>
           </a:graphicData>
         </a:graphic>
@@ -10153,7 +10107,7 @@
                 </a:solidFill>
                 <a:latin typeface="Calibri"/>
               </a:rPr>
-              <a:t>varias señales y el sentido de negocio</a:t>
+              <a:t>codo, silhouette y el sentido de negocio</a:t>
             </a:r>
             <a:r>
               <a:rPr sz="1200" b="0" i="0">
@@ -10162,7 +10116,7 @@
                 </a:solidFill>
                 <a:latin typeface="Calibri"/>
               </a:rPr>
-              <a:t>. Cuando se contradicen, dilo y prefiere la solución más simple que se pueda explicar y accionar.</a:t>
+              <a:t>. Cuando no coinciden, dilo y prefiere la solución más simple que se pueda explicar y accionar.</a:t>
             </a:r>
           </a:p>
         </p:txBody>

</xml_diff>